<commit_message>
I finished calculating the horizontal and lateral shadows, and drawing them in AutoCAD
</commit_message>
<xml_diff>
--- a/Illustration of Correction Angle.pptx
+++ b/Illustration of Correction Angle.pptx
@@ -197,7 +197,7 @@
           <a:p>
             <a:fld id="{9DC713DF-608D-488A-89CC-D754126EE7F6}" type="datetimeFigureOut">
               <a:rPr lang="en-US" smtClean="0"/>
-              <a:t>5/7/2026</a:t>
+              <a:t>5/8/2026</a:t>
             </a:fld>
             <a:endParaRPr lang="en-US"/>
           </a:p>
@@ -492,6 +492,13 @@
           </p:nvPr>
         </p:nvSpPr>
         <p:spPr/>
+        <p:txBody>
+          <a:bodyPr/>
+          <a:lstStyle/>
+          <a:p>
+            <a:endParaRPr lang="en-US"/>
+          </a:p>
+        </p:txBody>
       </p:sp>
       <p:sp>
         <p:nvSpPr>
@@ -695,7 +702,7 @@
           <a:p>
             <a:fld id="{39041C50-C169-48FA-A03E-FC77B214CE48}" type="datetimeFigureOut">
               <a:rPr lang="en-US" smtClean="0"/>
-              <a:t>5/7/2026</a:t>
+              <a:t>5/8/2026</a:t>
             </a:fld>
             <a:endParaRPr lang="en-US"/>
           </a:p>
@@ -893,7 +900,7 @@
           <a:p>
             <a:fld id="{39041C50-C169-48FA-A03E-FC77B214CE48}" type="datetimeFigureOut">
               <a:rPr lang="en-US" smtClean="0"/>
-              <a:t>5/7/2026</a:t>
+              <a:t>5/8/2026</a:t>
             </a:fld>
             <a:endParaRPr lang="en-US"/>
           </a:p>
@@ -1101,7 +1108,7 @@
           <a:p>
             <a:fld id="{39041C50-C169-48FA-A03E-FC77B214CE48}" type="datetimeFigureOut">
               <a:rPr lang="en-US" smtClean="0"/>
-              <a:t>5/7/2026</a:t>
+              <a:t>5/8/2026</a:t>
             </a:fld>
             <a:endParaRPr lang="en-US"/>
           </a:p>
@@ -1299,7 +1306,7 @@
           <a:p>
             <a:fld id="{39041C50-C169-48FA-A03E-FC77B214CE48}" type="datetimeFigureOut">
               <a:rPr lang="en-US" smtClean="0"/>
-              <a:t>5/7/2026</a:t>
+              <a:t>5/8/2026</a:t>
             </a:fld>
             <a:endParaRPr lang="en-US"/>
           </a:p>
@@ -1574,7 +1581,7 @@
           <a:p>
             <a:fld id="{39041C50-C169-48FA-A03E-FC77B214CE48}" type="datetimeFigureOut">
               <a:rPr lang="en-US" smtClean="0"/>
-              <a:t>5/7/2026</a:t>
+              <a:t>5/8/2026</a:t>
             </a:fld>
             <a:endParaRPr lang="en-US"/>
           </a:p>
@@ -1839,7 +1846,7 @@
           <a:p>
             <a:fld id="{39041C50-C169-48FA-A03E-FC77B214CE48}" type="datetimeFigureOut">
               <a:rPr lang="en-US" smtClean="0"/>
-              <a:t>5/7/2026</a:t>
+              <a:t>5/8/2026</a:t>
             </a:fld>
             <a:endParaRPr lang="en-US"/>
           </a:p>
@@ -2251,7 +2258,7 @@
           <a:p>
             <a:fld id="{39041C50-C169-48FA-A03E-FC77B214CE48}" type="datetimeFigureOut">
               <a:rPr lang="en-US" smtClean="0"/>
-              <a:t>5/7/2026</a:t>
+              <a:t>5/8/2026</a:t>
             </a:fld>
             <a:endParaRPr lang="en-US"/>
           </a:p>
@@ -2392,7 +2399,7 @@
           <a:p>
             <a:fld id="{39041C50-C169-48FA-A03E-FC77B214CE48}" type="datetimeFigureOut">
               <a:rPr lang="en-US" smtClean="0"/>
-              <a:t>5/7/2026</a:t>
+              <a:t>5/8/2026</a:t>
             </a:fld>
             <a:endParaRPr lang="en-US"/>
           </a:p>
@@ -2505,7 +2512,7 @@
           <a:p>
             <a:fld id="{39041C50-C169-48FA-A03E-FC77B214CE48}" type="datetimeFigureOut">
               <a:rPr lang="en-US" smtClean="0"/>
-              <a:t>5/7/2026</a:t>
+              <a:t>5/8/2026</a:t>
             </a:fld>
             <a:endParaRPr lang="en-US"/>
           </a:p>
@@ -2816,7 +2823,7 @@
           <a:p>
             <a:fld id="{39041C50-C169-48FA-A03E-FC77B214CE48}" type="datetimeFigureOut">
               <a:rPr lang="en-US" smtClean="0"/>
-              <a:t>5/7/2026</a:t>
+              <a:t>5/8/2026</a:t>
             </a:fld>
             <a:endParaRPr lang="en-US"/>
           </a:p>
@@ -3104,7 +3111,7 @@
           <a:p>
             <a:fld id="{39041C50-C169-48FA-A03E-FC77B214CE48}" type="datetimeFigureOut">
               <a:rPr lang="en-US" smtClean="0"/>
-              <a:t>5/7/2026</a:t>
+              <a:t>5/8/2026</a:t>
             </a:fld>
             <a:endParaRPr lang="en-US"/>
           </a:p>
@@ -3345,7 +3352,7 @@
           <a:p>
             <a:fld id="{39041C50-C169-48FA-A03E-FC77B214CE48}" type="datetimeFigureOut">
               <a:rPr lang="en-US" smtClean="0"/>
-              <a:t>5/7/2026</a:t>
+              <a:t>5/8/2026</a:t>
             </a:fld>
             <a:endParaRPr lang="en-US"/>
           </a:p>
@@ -4743,6 +4750,106 @@
             <a:endParaRPr lang="en-US" dirty="0">
               <a:solidFill>
                 <a:srgbClr val="F1EC0E"/>
+              </a:solidFill>
+              <a:latin typeface="Arial Rounded MT Bold" panose="020F0704030504030204" pitchFamily="34" charset="0"/>
+            </a:endParaRPr>
+          </a:p>
+        </p:txBody>
+      </p:sp>
+      <p:cxnSp>
+        <p:nvCxnSpPr>
+          <p:cNvPr id="7" name="Straight Connector 6">
+            <a:extLst>
+              <a:ext uri="{FF2B5EF4-FFF2-40B4-BE49-F238E27FC236}">
+                <a16:creationId xmlns:a16="http://schemas.microsoft.com/office/drawing/2014/main" id="{C27036F4-F109-AB87-304A-7BAC36EAFD3F}"/>
+              </a:ext>
+            </a:extLst>
+          </p:cNvPr>
+          <p:cNvCxnSpPr>
+            <a:cxnSpLocks/>
+          </p:cNvCxnSpPr>
+          <p:nvPr/>
+        </p:nvCxnSpPr>
+        <p:spPr>
+          <a:xfrm>
+            <a:off x="10276114" y="4832887"/>
+            <a:ext cx="265725" cy="797872"/>
+          </a:xfrm>
+          <a:prstGeom prst="line">
+            <a:avLst/>
+          </a:prstGeom>
+          <a:ln w="28575">
+            <a:solidFill>
+              <a:srgbClr val="FF0066"/>
+            </a:solidFill>
+            <a:headEnd type="arrow" w="med" len="med"/>
+            <a:tailEnd type="arrow" w="med" len="med"/>
+          </a:ln>
+        </p:spPr>
+        <p:style>
+          <a:lnRef idx="2">
+            <a:schemeClr val="accent1"/>
+          </a:lnRef>
+          <a:fillRef idx="0">
+            <a:schemeClr val="accent1"/>
+          </a:fillRef>
+          <a:effectRef idx="1">
+            <a:schemeClr val="accent1"/>
+          </a:effectRef>
+          <a:fontRef idx="minor">
+            <a:schemeClr val="tx1"/>
+          </a:fontRef>
+        </p:style>
+      </p:cxnSp>
+      <p:sp>
+        <p:nvSpPr>
+          <p:cNvPr id="14" name="TextBox 13">
+            <a:extLst>
+              <a:ext uri="{FF2B5EF4-FFF2-40B4-BE49-F238E27FC236}">
+                <a16:creationId xmlns:a16="http://schemas.microsoft.com/office/drawing/2014/main" id="{6F203268-59E1-6CF6-F79E-FEA9D0DE4271}"/>
+              </a:ext>
+            </a:extLst>
+          </p:cNvPr>
+          <p:cNvSpPr txBox="1"/>
+          <p:nvPr/>
+        </p:nvSpPr>
+        <p:spPr>
+          <a:xfrm>
+            <a:off x="10375570" y="4939989"/>
+            <a:ext cx="554960" cy="369332"/>
+          </a:xfrm>
+          <a:prstGeom prst="rect">
+            <a:avLst/>
+          </a:prstGeom>
+          <a:noFill/>
+        </p:spPr>
+        <p:txBody>
+          <a:bodyPr wrap="none" rtlCol="0">
+            <a:spAutoFit/>
+          </a:bodyPr>
+          <a:lstStyle/>
+          <a:p>
+            <a:r>
+              <a:rPr lang="en-US" dirty="0">
+                <a:solidFill>
+                  <a:srgbClr val="FF0066"/>
+                </a:solidFill>
+                <a:latin typeface="Arial Rounded MT Bold" panose="020F0704030504030204" pitchFamily="34" charset="0"/>
+              </a:rPr>
+              <a:t>D</a:t>
+            </a:r>
+            <a:r>
+              <a:rPr lang="en-US" sz="1000" dirty="0">
+                <a:solidFill>
+                  <a:srgbClr val="FF0066"/>
+                </a:solidFill>
+                <a:latin typeface="Arial Rounded MT Bold" panose="020F0704030504030204" pitchFamily="34" charset="0"/>
+              </a:rPr>
+              <a:t>Lat</a:t>
+            </a:r>
+            <a:endParaRPr lang="en-US" dirty="0">
+              <a:solidFill>
+                <a:srgbClr val="FF0066"/>
               </a:solidFill>
               <a:latin typeface="Arial Rounded MT Bold" panose="020F0704030504030204" pitchFamily="34" charset="0"/>
             </a:endParaRPr>

</xml_diff>

<commit_message>
I have finally finished analyzing and calculating the shadows
</commit_message>
<xml_diff>
--- a/Illustration of Correction Angle.pptx
+++ b/Illustration of Correction Angle.pptx
@@ -197,7 +197,7 @@
           <a:p>
             <a:fld id="{9DC713DF-608D-488A-89CC-D754126EE7F6}" type="datetimeFigureOut">
               <a:rPr lang="en-US" smtClean="0"/>
-              <a:t>5/8/2026</a:t>
+              <a:t>5/16/2026</a:t>
             </a:fld>
             <a:endParaRPr lang="en-US"/>
           </a:p>
@@ -702,7 +702,7 @@
           <a:p>
             <a:fld id="{39041C50-C169-48FA-A03E-FC77B214CE48}" type="datetimeFigureOut">
               <a:rPr lang="en-US" smtClean="0"/>
-              <a:t>5/8/2026</a:t>
+              <a:t>5/16/2026</a:t>
             </a:fld>
             <a:endParaRPr lang="en-US"/>
           </a:p>
@@ -900,7 +900,7 @@
           <a:p>
             <a:fld id="{39041C50-C169-48FA-A03E-FC77B214CE48}" type="datetimeFigureOut">
               <a:rPr lang="en-US" smtClean="0"/>
-              <a:t>5/8/2026</a:t>
+              <a:t>5/16/2026</a:t>
             </a:fld>
             <a:endParaRPr lang="en-US"/>
           </a:p>
@@ -1108,7 +1108,7 @@
           <a:p>
             <a:fld id="{39041C50-C169-48FA-A03E-FC77B214CE48}" type="datetimeFigureOut">
               <a:rPr lang="en-US" smtClean="0"/>
-              <a:t>5/8/2026</a:t>
+              <a:t>5/16/2026</a:t>
             </a:fld>
             <a:endParaRPr lang="en-US"/>
           </a:p>
@@ -1306,7 +1306,7 @@
           <a:p>
             <a:fld id="{39041C50-C169-48FA-A03E-FC77B214CE48}" type="datetimeFigureOut">
               <a:rPr lang="en-US" smtClean="0"/>
-              <a:t>5/8/2026</a:t>
+              <a:t>5/16/2026</a:t>
             </a:fld>
             <a:endParaRPr lang="en-US"/>
           </a:p>
@@ -1581,7 +1581,7 @@
           <a:p>
             <a:fld id="{39041C50-C169-48FA-A03E-FC77B214CE48}" type="datetimeFigureOut">
               <a:rPr lang="en-US" smtClean="0"/>
-              <a:t>5/8/2026</a:t>
+              <a:t>5/16/2026</a:t>
             </a:fld>
             <a:endParaRPr lang="en-US"/>
           </a:p>
@@ -1846,7 +1846,7 @@
           <a:p>
             <a:fld id="{39041C50-C169-48FA-A03E-FC77B214CE48}" type="datetimeFigureOut">
               <a:rPr lang="en-US" smtClean="0"/>
-              <a:t>5/8/2026</a:t>
+              <a:t>5/16/2026</a:t>
             </a:fld>
             <a:endParaRPr lang="en-US"/>
           </a:p>
@@ -2258,7 +2258,7 @@
           <a:p>
             <a:fld id="{39041C50-C169-48FA-A03E-FC77B214CE48}" type="datetimeFigureOut">
               <a:rPr lang="en-US" smtClean="0"/>
-              <a:t>5/8/2026</a:t>
+              <a:t>5/16/2026</a:t>
             </a:fld>
             <a:endParaRPr lang="en-US"/>
           </a:p>
@@ -2399,7 +2399,7 @@
           <a:p>
             <a:fld id="{39041C50-C169-48FA-A03E-FC77B214CE48}" type="datetimeFigureOut">
               <a:rPr lang="en-US" smtClean="0"/>
-              <a:t>5/8/2026</a:t>
+              <a:t>5/16/2026</a:t>
             </a:fld>
             <a:endParaRPr lang="en-US"/>
           </a:p>
@@ -2512,7 +2512,7 @@
           <a:p>
             <a:fld id="{39041C50-C169-48FA-A03E-FC77B214CE48}" type="datetimeFigureOut">
               <a:rPr lang="en-US" smtClean="0"/>
-              <a:t>5/8/2026</a:t>
+              <a:t>5/16/2026</a:t>
             </a:fld>
             <a:endParaRPr lang="en-US"/>
           </a:p>
@@ -2823,7 +2823,7 @@
           <a:p>
             <a:fld id="{39041C50-C169-48FA-A03E-FC77B214CE48}" type="datetimeFigureOut">
               <a:rPr lang="en-US" smtClean="0"/>
-              <a:t>5/8/2026</a:t>
+              <a:t>5/16/2026</a:t>
             </a:fld>
             <a:endParaRPr lang="en-US"/>
           </a:p>
@@ -3111,7 +3111,7 @@
           <a:p>
             <a:fld id="{39041C50-C169-48FA-A03E-FC77B214CE48}" type="datetimeFigureOut">
               <a:rPr lang="en-US" smtClean="0"/>
-              <a:t>5/8/2026</a:t>
+              <a:t>5/16/2026</a:t>
             </a:fld>
             <a:endParaRPr lang="en-US"/>
           </a:p>
@@ -3352,7 +3352,7 @@
           <a:p>
             <a:fld id="{39041C50-C169-48FA-A03E-FC77B214CE48}" type="datetimeFigureOut">
               <a:rPr lang="en-US" smtClean="0"/>
-              <a:t>5/8/2026</a:t>
+              <a:t>5/16/2026</a:t>
             </a:fld>
             <a:endParaRPr lang="en-US"/>
           </a:p>
@@ -3818,58 +3818,6 @@
           </a:p>
         </p:txBody>
       </p:sp>
-      <p:sp>
-        <p:nvSpPr>
-          <p:cNvPr id="5" name="Parallelogram 4">
-            <a:extLst>
-              <a:ext uri="{FF2B5EF4-FFF2-40B4-BE49-F238E27FC236}">
-                <a16:creationId xmlns:a16="http://schemas.microsoft.com/office/drawing/2014/main" id="{8B004778-4FC0-B713-BBDA-4087770A03B5}"/>
-              </a:ext>
-            </a:extLst>
-          </p:cNvPr>
-          <p:cNvSpPr/>
-          <p:nvPr/>
-        </p:nvSpPr>
-        <p:spPr>
-          <a:xfrm>
-            <a:off x="4404360" y="0"/>
-            <a:ext cx="7787640" cy="6858000"/>
-          </a:xfrm>
-          <a:prstGeom prst="parallelogram">
-            <a:avLst/>
-          </a:prstGeom>
-          <a:solidFill>
-            <a:srgbClr val="808080">
-              <a:alpha val="49804"/>
-            </a:srgbClr>
-          </a:solidFill>
-          <a:ln>
-            <a:noFill/>
-          </a:ln>
-        </p:spPr>
-        <p:style>
-          <a:lnRef idx="0">
-            <a:scrgbClr r="0" g="0" b="0"/>
-          </a:lnRef>
-          <a:fillRef idx="0">
-            <a:scrgbClr r="0" g="0" b="0"/>
-          </a:fillRef>
-          <a:effectRef idx="0">
-            <a:scrgbClr r="0" g="0" b="0"/>
-          </a:effectRef>
-          <a:fontRef idx="minor">
-            <a:schemeClr val="lt1"/>
-          </a:fontRef>
-        </p:style>
-        <p:txBody>
-          <a:bodyPr rtlCol="0" anchor="ctr"/>
-          <a:lstStyle/>
-          <a:p>
-            <a:pPr algn="ctr"/>
-            <a:endParaRPr lang="en-US" dirty="0"/>
-          </a:p>
-        </p:txBody>
-      </p:sp>
       <p:cxnSp>
         <p:nvCxnSpPr>
           <p:cNvPr id="13" name="Straight Connector 12">
@@ -3887,7 +3835,7 @@
         <p:spPr>
           <a:xfrm>
             <a:off x="5260954" y="3691570"/>
-            <a:ext cx="6030410" cy="0"/>
+            <a:ext cx="6712606" cy="0"/>
           </a:xfrm>
           <a:prstGeom prst="line">
             <a:avLst/>
@@ -4170,9 +4118,9 @@
           <p:nvPr/>
         </p:nvCxnSpPr>
         <p:spPr>
-          <a:xfrm>
-            <a:off x="4919241" y="4837464"/>
-            <a:ext cx="6030410" cy="0"/>
+          <a:xfrm flipV="1">
+            <a:off x="4919241" y="4832887"/>
+            <a:ext cx="7188939" cy="4577"/>
           </a:xfrm>
           <a:prstGeom prst="line">
             <a:avLst/>
@@ -4359,8 +4307,8 @@
         </p:nvSpPr>
         <p:spPr>
           <a:xfrm rot="6671987" flipH="1">
-            <a:off x="10168612" y="5344739"/>
-            <a:ext cx="487919" cy="413740"/>
+            <a:off x="10119576" y="5313645"/>
+            <a:ext cx="511988" cy="400093"/>
           </a:xfrm>
           <a:prstGeom prst="arc">
             <a:avLst>
@@ -4370,7 +4318,10 @@
           </a:prstGeom>
           <a:ln w="9525" cap="flat">
             <a:solidFill>
-              <a:srgbClr val="F1EC0E"/>
+              <a:schemeClr val="tx1">
+                <a:lumMod val="95000"/>
+                <a:lumOff val="5000"/>
+              </a:schemeClr>
             </a:solidFill>
             <a:round/>
             <a:headEnd type="arrow" w="sm" len="sm"/>
@@ -4396,7 +4347,11 @@
           <a:lstStyle/>
           <a:p>
             <a:pPr algn="ctr"/>
-            <a:endParaRPr lang="en-US" dirty="0"/>
+            <a:endParaRPr lang="en-US" dirty="0">
+              <a:highlight>
+                <a:srgbClr val="FFFF00"/>
+              </a:highlight>
+            </a:endParaRPr>
           </a:p>
         </p:txBody>
       </p:sp>
@@ -4682,8 +4637,8 @@
         </p:nvSpPr>
         <p:spPr>
           <a:xfrm>
-            <a:off x="9151975" y="4832887"/>
-            <a:ext cx="597065" cy="276999"/>
+            <a:off x="9149996" y="4804723"/>
+            <a:ext cx="704495" cy="307777"/>
           </a:xfrm>
           <a:prstGeom prst="rect">
             <a:avLst/>
@@ -4698,14 +4653,29 @@
           <a:p>
             <a:pPr algn="ctr"/>
             <a:r>
-              <a:rPr lang="en-US" sz="600" dirty="0">
+              <a:rPr lang="en-US" sz="1400" dirty="0">
                 <a:solidFill>
                   <a:srgbClr val="C00000"/>
                 </a:solidFill>
                 <a:latin typeface="Arial Rounded MT Bold" panose="020F0704030504030204" pitchFamily="34" charset="0"/>
               </a:rPr>
-              <a:t>Correction Angle</a:t>
-            </a:r>
+              <a:t>ψ</a:t>
+            </a:r>
+            <a:r>
+              <a:rPr lang="en-US" sz="500" dirty="0">
+                <a:solidFill>
+                  <a:srgbClr val="C00000"/>
+                </a:solidFill>
+                <a:latin typeface="Arial Rounded MT Bold" panose="020F0704030504030204" pitchFamily="34" charset="0"/>
+              </a:rPr>
+              <a:t>Correction</a:t>
+            </a:r>
+            <a:endParaRPr lang="en-US" sz="600" dirty="0">
+              <a:solidFill>
+                <a:srgbClr val="C00000"/>
+              </a:solidFill>
+              <a:latin typeface="Arial Rounded MT Bold" panose="020F0704030504030204" pitchFamily="34" charset="0"/>
+            </a:endParaRPr>
           </a:p>
         </p:txBody>
       </p:sp>
@@ -4723,8 +4693,8 @@
         </p:nvSpPr>
         <p:spPr>
           <a:xfrm>
-            <a:off x="10000197" y="5183820"/>
-            <a:ext cx="296892" cy="307777"/>
+            <a:off x="10026068" y="5169094"/>
+            <a:ext cx="178534" cy="307777"/>
           </a:xfrm>
           <a:prstGeom prst="rect">
             <a:avLst/>
@@ -4741,7 +4711,10 @@
             <a:r>
               <a:rPr lang="en-US" sz="1400" dirty="0">
                 <a:solidFill>
-                  <a:srgbClr val="F1EC0E"/>
+                  <a:schemeClr val="tx1">
+                    <a:lumMod val="95000"/>
+                    <a:lumOff val="5000"/>
+                  </a:schemeClr>
                 </a:solidFill>
                 <a:latin typeface="Arial Rounded MT Bold" panose="020F0704030504030204" pitchFamily="34" charset="0"/>
               </a:rPr>
@@ -4749,107 +4722,10 @@
             </a:r>
             <a:endParaRPr lang="en-US" dirty="0">
               <a:solidFill>
-                <a:srgbClr val="F1EC0E"/>
-              </a:solidFill>
-              <a:latin typeface="Arial Rounded MT Bold" panose="020F0704030504030204" pitchFamily="34" charset="0"/>
-            </a:endParaRPr>
-          </a:p>
-        </p:txBody>
-      </p:sp>
-      <p:cxnSp>
-        <p:nvCxnSpPr>
-          <p:cNvPr id="7" name="Straight Connector 6">
-            <a:extLst>
-              <a:ext uri="{FF2B5EF4-FFF2-40B4-BE49-F238E27FC236}">
-                <a16:creationId xmlns:a16="http://schemas.microsoft.com/office/drawing/2014/main" id="{C27036F4-F109-AB87-304A-7BAC36EAFD3F}"/>
-              </a:ext>
-            </a:extLst>
-          </p:cNvPr>
-          <p:cNvCxnSpPr>
-            <a:cxnSpLocks/>
-          </p:cNvCxnSpPr>
-          <p:nvPr/>
-        </p:nvCxnSpPr>
-        <p:spPr>
-          <a:xfrm>
-            <a:off x="10276114" y="4832887"/>
-            <a:ext cx="265725" cy="797872"/>
-          </a:xfrm>
-          <a:prstGeom prst="line">
-            <a:avLst/>
-          </a:prstGeom>
-          <a:ln w="28575">
-            <a:solidFill>
-              <a:srgbClr val="FF0066"/>
-            </a:solidFill>
-            <a:headEnd type="arrow" w="med" len="med"/>
-            <a:tailEnd type="arrow" w="med" len="med"/>
-          </a:ln>
-        </p:spPr>
-        <p:style>
-          <a:lnRef idx="2">
-            <a:schemeClr val="accent1"/>
-          </a:lnRef>
-          <a:fillRef idx="0">
-            <a:schemeClr val="accent1"/>
-          </a:fillRef>
-          <a:effectRef idx="1">
-            <a:schemeClr val="accent1"/>
-          </a:effectRef>
-          <a:fontRef idx="minor">
-            <a:schemeClr val="tx1"/>
-          </a:fontRef>
-        </p:style>
-      </p:cxnSp>
-      <p:sp>
-        <p:nvSpPr>
-          <p:cNvPr id="14" name="TextBox 13">
-            <a:extLst>
-              <a:ext uri="{FF2B5EF4-FFF2-40B4-BE49-F238E27FC236}">
-                <a16:creationId xmlns:a16="http://schemas.microsoft.com/office/drawing/2014/main" id="{6F203268-59E1-6CF6-F79E-FEA9D0DE4271}"/>
-              </a:ext>
-            </a:extLst>
-          </p:cNvPr>
-          <p:cNvSpPr txBox="1"/>
-          <p:nvPr/>
-        </p:nvSpPr>
-        <p:spPr>
-          <a:xfrm>
-            <a:off x="10375570" y="4939989"/>
-            <a:ext cx="554960" cy="369332"/>
-          </a:xfrm>
-          <a:prstGeom prst="rect">
-            <a:avLst/>
-          </a:prstGeom>
-          <a:noFill/>
-        </p:spPr>
-        <p:txBody>
-          <a:bodyPr wrap="none" rtlCol="0">
-            <a:spAutoFit/>
-          </a:bodyPr>
-          <a:lstStyle/>
-          <a:p>
-            <a:r>
-              <a:rPr lang="en-US" dirty="0">
-                <a:solidFill>
-                  <a:srgbClr val="FF0066"/>
-                </a:solidFill>
-                <a:latin typeface="Arial Rounded MT Bold" panose="020F0704030504030204" pitchFamily="34" charset="0"/>
-              </a:rPr>
-              <a:t>D</a:t>
-            </a:r>
-            <a:r>
-              <a:rPr lang="en-US" sz="1000" dirty="0">
-                <a:solidFill>
-                  <a:srgbClr val="FF0066"/>
-                </a:solidFill>
-                <a:latin typeface="Arial Rounded MT Bold" panose="020F0704030504030204" pitchFamily="34" charset="0"/>
-              </a:rPr>
-              <a:t>Lat</a:t>
-            </a:r>
-            <a:endParaRPr lang="en-US" dirty="0">
-              <a:solidFill>
-                <a:srgbClr val="FF0066"/>
+                <a:schemeClr val="tx1">
+                  <a:lumMod val="95000"/>
+                  <a:lumOff val="5000"/>
+                </a:schemeClr>
               </a:solidFill>
               <a:latin typeface="Arial Rounded MT Bold" panose="020F0704030504030204" pitchFamily="34" charset="0"/>
             </a:endParaRPr>

</xml_diff>